<commit_message>
fixing the activies and lectures slowly - this is a working version of the folder and there is a back up
</commit_message>
<xml_diff>
--- a/docs/content/analysis_of_variance/11_04_how_anova_is_dummy_var_regression.pptx
+++ b/docs/content/analysis_of_variance/11_04_how_anova_is_dummy_var_regression.pptx
@@ -4203,7 +4203,7 @@
       </p:sp>
       <p:graphicFrame xmlns:a="http://schemas.openxmlformats.org/drawingml/2006/main" xmlns:r="http://schemas.openxmlformats.org/officeDocument/2006/relationships" xmlns:p="http://schemas.openxmlformats.org/presentationml/2006/main">
         <p:nvGraphicFramePr>
-          <p:cNvPr id="887549793" name=""/>
+          <p:cNvPr id="356598473" name=""/>
           <p:cNvGraphicFramePr>
             <a:graphicFrameLocks noGrp="true"/>
           </p:cNvGraphicFramePr>
@@ -4304,7 +4304,7 @@
       </p:sp>
       <p:graphicFrame xmlns:a="http://schemas.openxmlformats.org/drawingml/2006/main" xmlns:r="http://schemas.openxmlformats.org/officeDocument/2006/relationships" xmlns:p="http://schemas.openxmlformats.org/presentationml/2006/main">
         <p:nvGraphicFramePr>
-          <p:cNvPr id="863373409" name=""/>
+          <p:cNvPr id="79676922" name=""/>
           <p:cNvGraphicFramePr>
             <a:graphicFrameLocks noGrp="true"/>
           </p:cNvGraphicFramePr>
@@ -5187,7 +5187,7 @@
       </p:sp>
       <p:graphicFrame xmlns:a="http://schemas.openxmlformats.org/drawingml/2006/main" xmlns:r="http://schemas.openxmlformats.org/officeDocument/2006/relationships" xmlns:p="http://schemas.openxmlformats.org/presentationml/2006/main">
         <p:nvGraphicFramePr>
-          <p:cNvPr id="933811747" name=""/>
+          <p:cNvPr id="583344632" name=""/>
           <p:cNvGraphicFramePr>
             <a:graphicFrameLocks noGrp="true"/>
           </p:cNvGraphicFramePr>
@@ -6750,7 +6750,7 @@
       </p:sp>
       <p:graphicFrame xmlns:a="http://schemas.openxmlformats.org/drawingml/2006/main" xmlns:r="http://schemas.openxmlformats.org/officeDocument/2006/relationships" xmlns:p="http://schemas.openxmlformats.org/presentationml/2006/main">
         <p:nvGraphicFramePr>
-          <p:cNvPr id="385917841" name=""/>
+          <p:cNvPr id="610629432" name=""/>
           <p:cNvGraphicFramePr>
             <a:graphicFrameLocks noGrp="true"/>
           </p:cNvGraphicFramePr>

</xml_diff>

<commit_message>
updated slides 01 - 04  wiht ## for slide and # for section and fixed boxes around output
</commit_message>
<xml_diff>
--- a/docs/content/analysis_of_variance/11_04_how_anova_is_dummy_var_regression.pptx
+++ b/docs/content/analysis_of_variance/11_04_how_anova_is_dummy_var_regression.pptx
@@ -4203,7 +4203,7 @@
       </p:sp>
       <p:graphicFrame xmlns:a="http://schemas.openxmlformats.org/drawingml/2006/main" xmlns:r="http://schemas.openxmlformats.org/officeDocument/2006/relationships" xmlns:p="http://schemas.openxmlformats.org/presentationml/2006/main">
         <p:nvGraphicFramePr>
-          <p:cNvPr id="356598473" name=""/>
+          <p:cNvPr id="817284253" name=""/>
           <p:cNvGraphicFramePr>
             <a:graphicFrameLocks noGrp="true"/>
           </p:cNvGraphicFramePr>
@@ -4304,7 +4304,7 @@
       </p:sp>
       <p:graphicFrame xmlns:a="http://schemas.openxmlformats.org/drawingml/2006/main" xmlns:r="http://schemas.openxmlformats.org/officeDocument/2006/relationships" xmlns:p="http://schemas.openxmlformats.org/presentationml/2006/main">
         <p:nvGraphicFramePr>
-          <p:cNvPr id="79676922" name=""/>
+          <p:cNvPr id="505229646" name=""/>
           <p:cNvGraphicFramePr>
             <a:graphicFrameLocks noGrp="true"/>
           </p:cNvGraphicFramePr>
@@ -5187,7 +5187,7 @@
       </p:sp>
       <p:graphicFrame xmlns:a="http://schemas.openxmlformats.org/drawingml/2006/main" xmlns:r="http://schemas.openxmlformats.org/officeDocument/2006/relationships" xmlns:p="http://schemas.openxmlformats.org/presentationml/2006/main">
         <p:nvGraphicFramePr>
-          <p:cNvPr id="583344632" name=""/>
+          <p:cNvPr id="712851501" name=""/>
           <p:cNvGraphicFramePr>
             <a:graphicFrameLocks noGrp="true"/>
           </p:cNvGraphicFramePr>
@@ -6750,7 +6750,7 @@
       </p:sp>
       <p:graphicFrame xmlns:a="http://schemas.openxmlformats.org/drawingml/2006/main" xmlns:r="http://schemas.openxmlformats.org/officeDocument/2006/relationships" xmlns:p="http://schemas.openxmlformats.org/presentationml/2006/main">
         <p:nvGraphicFramePr>
-          <p:cNvPr id="610629432" name=""/>
+          <p:cNvPr id="271157222" name=""/>
           <p:cNvGraphicFramePr>
             <a:graphicFrameLocks noGrp="true"/>
           </p:cNvGraphicFramePr>

</xml_diff>

<commit_message>
quizzes are done now
</commit_message>
<xml_diff>
--- a/docs/content/analysis_of_variance/11_04_how_anova_is_dummy_var_regression.pptx
+++ b/docs/content/analysis_of_variance/11_04_how_anova_is_dummy_var_regression.pptx
@@ -4203,7 +4203,7 @@
       </p:sp>
       <p:graphicFrame xmlns:a="http://schemas.openxmlformats.org/drawingml/2006/main" xmlns:r="http://schemas.openxmlformats.org/officeDocument/2006/relationships" xmlns:p="http://schemas.openxmlformats.org/presentationml/2006/main">
         <p:nvGraphicFramePr>
-          <p:cNvPr id="979007574" name=""/>
+          <p:cNvPr id="131777239" name=""/>
           <p:cNvGraphicFramePr>
             <a:graphicFrameLocks noGrp="true"/>
           </p:cNvGraphicFramePr>
@@ -4304,7 +4304,7 @@
       </p:sp>
       <p:graphicFrame xmlns:a="http://schemas.openxmlformats.org/drawingml/2006/main" xmlns:r="http://schemas.openxmlformats.org/officeDocument/2006/relationships" xmlns:p="http://schemas.openxmlformats.org/presentationml/2006/main">
         <p:nvGraphicFramePr>
-          <p:cNvPr id="366476804" name=""/>
+          <p:cNvPr id="145137471" name=""/>
           <p:cNvGraphicFramePr>
             <a:graphicFrameLocks noGrp="true"/>
           </p:cNvGraphicFramePr>
@@ -4887,8 +4887,8 @@
         </p:blipFill>
         <p:spPr bwMode="auto">
           <a:xfrm>
-            <a:off x="3657600" y="1244600"/>
-            <a:ext cx="5232400" cy="3225800"/>
+            <a:off x="4368800" y="952500"/>
+            <a:ext cx="3797300" cy="3797300"/>
           </a:xfrm>
           <a:prstGeom prst="rect">
             <a:avLst/>
@@ -5187,7 +5187,7 @@
       </p:sp>
       <p:graphicFrame xmlns:a="http://schemas.openxmlformats.org/drawingml/2006/main" xmlns:r="http://schemas.openxmlformats.org/officeDocument/2006/relationships" xmlns:p="http://schemas.openxmlformats.org/presentationml/2006/main">
         <p:nvGraphicFramePr>
-          <p:cNvPr id="789364485" name=""/>
+          <p:cNvPr id="779082498" name=""/>
           <p:cNvGraphicFramePr>
             <a:graphicFrameLocks noGrp="true"/>
           </p:cNvGraphicFramePr>
@@ -6541,8 +6541,8 @@
         </p:blipFill>
         <p:spPr bwMode="auto">
           <a:xfrm>
-            <a:off x="3657600" y="1244600"/>
-            <a:ext cx="5232400" cy="3225800"/>
+            <a:off x="4368800" y="952500"/>
+            <a:ext cx="3797300" cy="3797300"/>
           </a:xfrm>
           <a:prstGeom prst="rect">
             <a:avLst/>
@@ -6657,8 +6657,8 @@
         </p:blipFill>
         <p:spPr bwMode="auto">
           <a:xfrm>
-            <a:off x="3657600" y="1244600"/>
-            <a:ext cx="5232400" cy="3225800"/>
+            <a:off x="4368800" y="952500"/>
+            <a:ext cx="3797300" cy="3797300"/>
           </a:xfrm>
           <a:prstGeom prst="rect">
             <a:avLst/>
@@ -6750,7 +6750,7 @@
       </p:sp>
       <p:graphicFrame xmlns:a="http://schemas.openxmlformats.org/drawingml/2006/main" xmlns:r="http://schemas.openxmlformats.org/officeDocument/2006/relationships" xmlns:p="http://schemas.openxmlformats.org/presentationml/2006/main">
         <p:nvGraphicFramePr>
-          <p:cNvPr id="357456873" name=""/>
+          <p:cNvPr id="835937533" name=""/>
           <p:cNvGraphicFramePr>
             <a:graphicFrameLocks noGrp="true"/>
           </p:cNvGraphicFramePr>

</xml_diff>

<commit_message>
fixed finally almost there
</commit_message>
<xml_diff>
--- a/docs/content/analysis_of_variance/11_04_how_anova_is_dummy_var_regression.pptx
+++ b/docs/content/analysis_of_variance/11_04_how_anova_is_dummy_var_regression.pptx
@@ -4203,7 +4203,7 @@
       </p:sp>
       <p:graphicFrame xmlns:a="http://schemas.openxmlformats.org/drawingml/2006/main" xmlns:r="http://schemas.openxmlformats.org/officeDocument/2006/relationships" xmlns:p="http://schemas.openxmlformats.org/presentationml/2006/main">
         <p:nvGraphicFramePr>
-          <p:cNvPr id="437464959" name=""/>
+          <p:cNvPr id="546686074" name=""/>
           <p:cNvGraphicFramePr>
             <a:graphicFrameLocks noGrp="true"/>
           </p:cNvGraphicFramePr>
@@ -4304,7 +4304,7 @@
       </p:sp>
       <p:graphicFrame xmlns:a="http://schemas.openxmlformats.org/drawingml/2006/main" xmlns:r="http://schemas.openxmlformats.org/officeDocument/2006/relationships" xmlns:p="http://schemas.openxmlformats.org/presentationml/2006/main">
         <p:nvGraphicFramePr>
-          <p:cNvPr id="453045193" name=""/>
+          <p:cNvPr id="634603336" name=""/>
           <p:cNvGraphicFramePr>
             <a:graphicFrameLocks noGrp="true"/>
           </p:cNvGraphicFramePr>
@@ -5187,7 +5187,7 @@
       </p:sp>
       <p:graphicFrame xmlns:a="http://schemas.openxmlformats.org/drawingml/2006/main" xmlns:r="http://schemas.openxmlformats.org/officeDocument/2006/relationships" xmlns:p="http://schemas.openxmlformats.org/presentationml/2006/main">
         <p:nvGraphicFramePr>
-          <p:cNvPr id="384083219" name=""/>
+          <p:cNvPr id="506179075" name=""/>
           <p:cNvGraphicFramePr>
             <a:graphicFrameLocks noGrp="true"/>
           </p:cNvGraphicFramePr>
@@ -6750,7 +6750,7 @@
       </p:sp>
       <p:graphicFrame xmlns:a="http://schemas.openxmlformats.org/drawingml/2006/main" xmlns:r="http://schemas.openxmlformats.org/officeDocument/2006/relationships" xmlns:p="http://schemas.openxmlformats.org/presentationml/2006/main">
         <p:nvGraphicFramePr>
-          <p:cNvPr id="237349294" name=""/>
+          <p:cNvPr id="36381421" name=""/>
           <p:cNvGraphicFramePr>
             <a:graphicFrameLocks noGrp="true"/>
           </p:cNvGraphicFramePr>

</xml_diff>

<commit_message>
fixed a few of the pages t test and othes
</commit_message>
<xml_diff>
--- a/docs/content/analysis_of_variance/11_04_how_anova_is_dummy_var_regression.pptx
+++ b/docs/content/analysis_of_variance/11_04_how_anova_is_dummy_var_regression.pptx
@@ -4203,7 +4203,7 @@
       </p:sp>
       <p:graphicFrame xmlns:a="http://schemas.openxmlformats.org/drawingml/2006/main" xmlns:r="http://schemas.openxmlformats.org/officeDocument/2006/relationships" xmlns:p="http://schemas.openxmlformats.org/presentationml/2006/main">
         <p:nvGraphicFramePr>
-          <p:cNvPr id="546686074" name=""/>
+          <p:cNvPr id="864920921" name=""/>
           <p:cNvGraphicFramePr>
             <a:graphicFrameLocks noGrp="true"/>
           </p:cNvGraphicFramePr>
@@ -4304,7 +4304,7 @@
       </p:sp>
       <p:graphicFrame xmlns:a="http://schemas.openxmlformats.org/drawingml/2006/main" xmlns:r="http://schemas.openxmlformats.org/officeDocument/2006/relationships" xmlns:p="http://schemas.openxmlformats.org/presentationml/2006/main">
         <p:nvGraphicFramePr>
-          <p:cNvPr id="634603336" name=""/>
+          <p:cNvPr id="579171627" name=""/>
           <p:cNvGraphicFramePr>
             <a:graphicFrameLocks noGrp="true"/>
           </p:cNvGraphicFramePr>
@@ -5187,7 +5187,7 @@
       </p:sp>
       <p:graphicFrame xmlns:a="http://schemas.openxmlformats.org/drawingml/2006/main" xmlns:r="http://schemas.openxmlformats.org/officeDocument/2006/relationships" xmlns:p="http://schemas.openxmlformats.org/presentationml/2006/main">
         <p:nvGraphicFramePr>
-          <p:cNvPr id="506179075" name=""/>
+          <p:cNvPr id="78537759" name=""/>
           <p:cNvGraphicFramePr>
             <a:graphicFrameLocks noGrp="true"/>
           </p:cNvGraphicFramePr>
@@ -6750,7 +6750,7 @@
       </p:sp>
       <p:graphicFrame xmlns:a="http://schemas.openxmlformats.org/drawingml/2006/main" xmlns:r="http://schemas.openxmlformats.org/officeDocument/2006/relationships" xmlns:p="http://schemas.openxmlformats.org/presentationml/2006/main">
         <p:nvGraphicFramePr>
-          <p:cNvPr id="36381421" name=""/>
+          <p:cNvPr id="690902222" name=""/>
           <p:cNvGraphicFramePr>
             <a:graphicFrameLocks noGrp="true"/>
           </p:cNvGraphicFramePr>

</xml_diff>

<commit_message>
fixed lmm and nested
</commit_message>
<xml_diff>
--- a/docs/content/analysis_of_variance/11_04_how_anova_is_dummy_var_regression.pptx
+++ b/docs/content/analysis_of_variance/11_04_how_anova_is_dummy_var_regression.pptx
@@ -4203,7 +4203,7 @@
       </p:sp>
       <p:graphicFrame xmlns:a="http://schemas.openxmlformats.org/drawingml/2006/main" xmlns:r="http://schemas.openxmlformats.org/officeDocument/2006/relationships" xmlns:p="http://schemas.openxmlformats.org/presentationml/2006/main">
         <p:nvGraphicFramePr>
-          <p:cNvPr id="864920921" name=""/>
+          <p:cNvPr id="544713826" name=""/>
           <p:cNvGraphicFramePr>
             <a:graphicFrameLocks noGrp="true"/>
           </p:cNvGraphicFramePr>
@@ -4304,7 +4304,7 @@
       </p:sp>
       <p:graphicFrame xmlns:a="http://schemas.openxmlformats.org/drawingml/2006/main" xmlns:r="http://schemas.openxmlformats.org/officeDocument/2006/relationships" xmlns:p="http://schemas.openxmlformats.org/presentationml/2006/main">
         <p:nvGraphicFramePr>
-          <p:cNvPr id="579171627" name=""/>
+          <p:cNvPr id="705971515" name=""/>
           <p:cNvGraphicFramePr>
             <a:graphicFrameLocks noGrp="true"/>
           </p:cNvGraphicFramePr>
@@ -5187,7 +5187,7 @@
       </p:sp>
       <p:graphicFrame xmlns:a="http://schemas.openxmlformats.org/drawingml/2006/main" xmlns:r="http://schemas.openxmlformats.org/officeDocument/2006/relationships" xmlns:p="http://schemas.openxmlformats.org/presentationml/2006/main">
         <p:nvGraphicFramePr>
-          <p:cNvPr id="78537759" name=""/>
+          <p:cNvPr id="11004343" name=""/>
           <p:cNvGraphicFramePr>
             <a:graphicFrameLocks noGrp="true"/>
           </p:cNvGraphicFramePr>
@@ -6750,7 +6750,7 @@
       </p:sp>
       <p:graphicFrame xmlns:a="http://schemas.openxmlformats.org/drawingml/2006/main" xmlns:r="http://schemas.openxmlformats.org/officeDocument/2006/relationships" xmlns:p="http://schemas.openxmlformats.org/presentationml/2006/main">
         <p:nvGraphicFramePr>
-          <p:cNvPr id="690902222" name=""/>
+          <p:cNvPr id="915618321" name=""/>
           <p:cNvGraphicFramePr>
             <a:graphicFrameLocks noGrp="true"/>
           </p:cNvGraphicFramePr>

</xml_diff>